<commit_message>
Fix privacy guard gaps and align agent counts across docs
- Block diagnosis requests containing diagnose/diagnosis/diagnosing
- Block plural antibiotic prescription requests (e.g. give me antibiotics)
- Update README, pitch page, dashboard, and presentation decks to
  reflect nine cooperating agents and current product surfaces
- Remove remaining UNICEF reference from India impact agent methodology

Co-authored-by: carbonintelli <carbonintelli@users.noreply.github.com>
</commit_message>
<xml_diff>
--- a/presentations/KlimaGuard-Kids-Check-In.pptx
+++ b/presentations/KlimaGuard-Kids-Check-In.pptx
@@ -3699,7 +3699,7 @@
               </a:defRPr>
             </a:pPr>
             <a:r>
-              <a:t>6</a:t>
+              <a:t>9</a:t>
             </a:r>
           </a:p>
         </p:txBody>
@@ -3983,7 +3983,7 @@
               </a:defRPr>
             </a:pPr>
             <a:r>
-              <a:t>Home, dashboard, and about pages</a:t>
+              <a:t>Home, dashboard, India, chat, and about pages</a:t>
             </a:r>
           </a:p>
           <a:p>
@@ -4101,7 +4101,7 @@
               </a:defRPr>
             </a:pPr>
             <a:r>
-              <a:t>Six-agent orchestration pipeline</a:t>
+              <a:t>Nine-agent orchestration pipeline</a:t>
             </a:r>
           </a:p>
           <a:p>
@@ -4116,7 +4116,7 @@
               </a:defRPr>
             </a:pPr>
             <a:r>
-              <a:t>REST API (/api/analyze, /api/countries)</a:t>
+              <a:t>REST API (/api/analyze, /api/chat, /api/countries)</a:t>
             </a:r>
           </a:p>
           <a:p>

</xml_diff>

<commit_message>
Document expanded geography, tiers, and validated sources
Add DATA_SOURCES_AND_GEOGRAPHY.md and align README, ARCHITECTURE,
UNGM, CONTRIBUTING, Training scripts, pitch copy, and presentation
generators with 159/482/77 coverage and ~50 trusted sources.

Co-authored-by: carbonintelli <carbonintelli@users.noreply.github.com>
</commit_message>
<xml_diff>
--- a/presentations/KlimaGuard-Kids-Check-In.pptx
+++ b/presentations/KlimaGuard-Kids-Check-In.pptx
@@ -3584,7 +3584,7 @@
               </a:defRPr>
             </a:pPr>
             <a:r>
-              <a:t>20</a:t>
+              <a:t>159</a:t>
             </a:r>
           </a:p>
         </p:txBody>
@@ -3619,7 +3619,7 @@
               </a:defRPr>
             </a:pPr>
             <a:r>
-              <a:t>Countries supported</a:t>
+              <a:t>Countries · 482 cities</a:t>
             </a:r>
           </a:p>
         </p:txBody>
@@ -3699,7 +3699,7 @@
               </a:defRPr>
             </a:pPr>
             <a:r>
-              <a:t>9</a:t>
+              <a:t>8</a:t>
             </a:r>
           </a:p>
         </p:txBody>
@@ -3983,7 +3983,7 @@
               </a:defRPr>
             </a:pPr>
             <a:r>
-              <a:t>Home, dashboard, India, chat, and about pages</a:t>
+              <a:t>Home, dashboard, India, play, and pitch pages</a:t>
             </a:r>
           </a:p>
           <a:p>
@@ -3998,7 +3998,7 @@
               </a:defRPr>
             </a:pPr>
             <a:r>
-              <a:t>Global country selector (20 countries)</a:t>
+              <a:t>Global Tier 1–3 city registry (159 / 482)</a:t>
             </a:r>
           </a:p>
           <a:p>
@@ -4013,7 +4013,7 @@
               </a:defRPr>
             </a:pPr>
             <a:r>
-              <a:t>Live Open-Meteo integration</a:t>
+              <a:t>77 India CHIS regions · ~50 validated sources</a:t>
             </a:r>
           </a:p>
           <a:p>
@@ -4028,7 +4028,7 @@
               </a:defRPr>
             </a:pPr>
             <a:r>
-              <a:t>Age-banded child guidance output</a:t>
+              <a:t>Age-banded child guidance + kids play</a:t>
             </a:r>
           </a:p>
         </p:txBody>
@@ -4101,7 +4101,7 @@
               </a:defRPr>
             </a:pPr>
             <a:r>
-              <a:t>Nine-agent orchestration pipeline</a:t>
+              <a:t>Eight-agent orchestration pipeline</a:t>
             </a:r>
           </a:p>
           <a:p>
@@ -4116,7 +4116,7 @@
               </a:defRPr>
             </a:pPr>
             <a:r>
-              <a:t>REST API (/api/analyze, /api/chat, /api/countries)</a:t>
+              <a:t>REST API (/api/analyze, /api/countries, /api/india/regions)</a:t>
             </a:r>
           </a:p>
           <a:p>

</xml_diff>